<commit_message>
Adopt dual-Surface preview (display via RS, analysis via ImageReceiver) in doc and deck
Co-authored-by: Lizzy67 <Lizzy67@users.noreply.github.com>
</commit_message>
<xml_diff>
--- a/artifacts/小艺CameraTab_UEC感知方案_评审.pptx
+++ b/artifacts/小艺CameraTab_UEC感知方案_评审.pptx
@@ -5057,7 +5057,7 @@
                 <a:latin typeface="Microsoft YaHei"/>
                 <a:ea typeface="Microsoft YaHei"/>
               </a:rPr>
-              <a:t>UEC 进程能否稳定拿到并显示预览</a:t>
+              <a:t>双 Surface：显示路 + 小艺分析路并发出流</a:t>
             </a:r>
           </a:p>
           <a:p>
@@ -5084,7 +5084,7 @@
                 <a:latin typeface="Microsoft YaHei"/>
                 <a:ea typeface="Microsoft YaHei"/>
               </a:rPr>
-              <a:t>宿主握机 + 小艺 Output 共存</a:t>
+              <a:t>UEC 内 XComponent 显示是否可用</a:t>
             </a:r>
           </a:p>
           <a:p>
@@ -6823,7 +6823,7 @@
                 <a:latin typeface="Microsoft YaHei"/>
                 <a:ea typeface="Microsoft YaHei"/>
               </a:rPr>
-              <a:t>相机 App 握相机 → 框架 → HDI → HAL；小艺 UEC 消费流、做感知与推荐；不直连 HAL / HDI。</a:t>
+              <a:t>相机 App 握相机 → 框架 → HDI → HAL，配「显示 + 分析」两路 Surface；小艺消费分析路做感知与推荐，不直连 HAL / HDI。</a:t>
             </a:r>
           </a:p>
         </p:txBody>
@@ -8697,7 +8697,7 @@
                 <a:latin typeface="Microsoft YaHei"/>
                 <a:ea typeface="Microsoft YaHei"/>
               </a:rPr>
-              <a:t>相机配流</a:t>
+              <a:t>双 Surface</a:t>
             </a:r>
           </a:p>
           <a:p>
@@ -8714,7 +8714,7 @@
                 <a:latin typeface="Microsoft YaHei"/>
                 <a:ea typeface="Microsoft YaHei"/>
               </a:rPr>
-              <a:t>小艺消费</a:t>
+              <a:t>显示 + 分析</a:t>
             </a:r>
           </a:p>
         </p:txBody>
@@ -10606,7 +10606,7 @@
                 <a:latin typeface="Microsoft YaHei"/>
                 <a:ea typeface="Microsoft YaHei"/>
               </a:rPr>
-              <a:t>连续：预览 Buffer + 运动 metadata（同 timestamp）</a:t>
+              <a:t>同一帧投两路 Output：Surface A（显示→RS）/ Surface B（分析→小艺）</a:t>
             </a:r>
           </a:p>
           <a:p>
@@ -10623,7 +10623,7 @@
                 <a:latin typeface="Microsoft YaHei"/>
                 <a:ea typeface="Microsoft YaHei"/>
               </a:rPr>
-              <a:t>按需：单次深度计算 + 对齐 RGB，可控停流</a:t>
+              <a:t>连续：预览 Buffer + 运动 meta（同 ts）；按需：单次深度 + 对齐 RGB</a:t>
             </a:r>
           </a:p>
         </p:txBody>
@@ -10888,7 +10888,374 @@
         <p:spPr>
           <a:xfrm>
             <a:off x="7040880" y="1691640"/>
-            <a:ext cx="4343400" cy="640080"/>
+            <a:ext cx="1508760" cy="640080"/>
+          </a:xfrm>
+          <a:prstGeom prst="roundRect">
+            <a:avLst>
+              <a:gd name="adj" fmla="val 12000"/>
+            </a:avLst>
+          </a:prstGeom>
+          <a:solidFill>
+            <a:srgbClr val="F1F5F9"/>
+          </a:solidFill>
+          <a:ln w="12700">
+            <a:solidFill>
+              <a:srgbClr val="94A3B8"/>
+            </a:solidFill>
+          </a:ln>
+          <a:effectLst/>
+        </p:spPr>
+        <p:style>
+          <a:lnRef idx="1">
+            <a:schemeClr val="accent1"/>
+          </a:lnRef>
+          <a:fillRef idx="3">
+            <a:schemeClr val="accent1"/>
+          </a:fillRef>
+          <a:effectRef idx="2">
+            <a:schemeClr val="accent1"/>
+          </a:effectRef>
+          <a:fontRef idx="minor">
+            <a:schemeClr val="lt1"/>
+          </a:fontRef>
+        </p:style>
+        <p:txBody>
+          <a:bodyPr rtlCol="0" anchor="ctr" wrap="square" lIns="63500" rIns="63500" tIns="38100" bIns="38100"/>
+          <a:lstStyle/>
+          <a:p>
+            <a:pPr algn="ctr"/>
+            <a:r>
+              <a:rPr sz="1000" b="1">
+                <a:solidFill>
+                  <a:srgbClr val="0F172A"/>
+                </a:solidFill>
+                <a:latin typeface="Microsoft YaHei"/>
+                <a:ea typeface="Microsoft YaHei"/>
+              </a:rPr>
+              <a:t>Surface A · 显示路</a:t>
+            </a:r>
+          </a:p>
+          <a:p>
+            <a:pPr algn="ctr">
+              <a:spcBef>
+                <a:spcPts val="0"/>
+              </a:spcBef>
+            </a:pPr>
+            <a:r>
+              <a:rPr sz="800" b="0">
+                <a:solidFill>
+                  <a:srgbClr val="64748B"/>
+                </a:solidFill>
+                <a:latin typeface="Microsoft YaHei"/>
+                <a:ea typeface="Microsoft YaHei"/>
+              </a:rPr>
+              <a:t>消费者 = RS 直达屏幕</a:t>
+            </a:r>
+          </a:p>
+        </p:txBody>
+      </p:sp>
+      <p:sp>
+        <p:nvSpPr>
+          <p:cNvPr id="28" name="Rounded Rectangle 27"/>
+          <p:cNvSpPr/>
+          <p:nvPr/>
+        </p:nvSpPr>
+        <p:spPr>
+          <a:xfrm>
+            <a:off x="8641080" y="1691640"/>
+            <a:ext cx="2743200" cy="640080"/>
+          </a:xfrm>
+          <a:prstGeom prst="roundRect">
+            <a:avLst>
+              <a:gd name="adj" fmla="val 12000"/>
+            </a:avLst>
+          </a:prstGeom>
+          <a:solidFill>
+            <a:srgbClr val="D1FAE5"/>
+          </a:solidFill>
+          <a:ln w="12700">
+            <a:solidFill>
+              <a:srgbClr val="059669"/>
+            </a:solidFill>
+          </a:ln>
+          <a:effectLst/>
+        </p:spPr>
+        <p:style>
+          <a:lnRef idx="1">
+            <a:schemeClr val="accent1"/>
+          </a:lnRef>
+          <a:fillRef idx="3">
+            <a:schemeClr val="accent1"/>
+          </a:fillRef>
+          <a:effectRef idx="2">
+            <a:schemeClr val="accent1"/>
+          </a:effectRef>
+          <a:fontRef idx="minor">
+            <a:schemeClr val="lt1"/>
+          </a:fontRef>
+        </p:style>
+        <p:txBody>
+          <a:bodyPr rtlCol="0" anchor="ctr" wrap="square" lIns="63500" rIns="63500" tIns="38100" bIns="38100"/>
+          <a:lstStyle/>
+          <a:p>
+            <a:pPr algn="ctr"/>
+            <a:r>
+              <a:rPr sz="1000" b="1">
+                <a:solidFill>
+                  <a:srgbClr val="0F172A"/>
+                </a:solidFill>
+                <a:latin typeface="Microsoft YaHei"/>
+                <a:ea typeface="Microsoft YaHei"/>
+              </a:rPr>
+              <a:t>Surface B · 分析路（ImageReceiver）</a:t>
+            </a:r>
+          </a:p>
+          <a:p>
+            <a:pPr algn="ctr">
+              <a:spcBef>
+                <a:spcPts val="0"/>
+              </a:spcBef>
+            </a:pPr>
+            <a:r>
+              <a:rPr sz="800" b="0">
+                <a:solidFill>
+                  <a:srgbClr val="64748B"/>
+                </a:solidFill>
+                <a:latin typeface="Microsoft YaHei"/>
+                <a:ea typeface="Microsoft YaHei"/>
+              </a:rPr>
+              <a:t>消费者 = 小艺；小图低帧率；acquire→处理→release</a:t>
+            </a:r>
+          </a:p>
+        </p:txBody>
+      </p:sp>
+      <p:cxnSp>
+        <p:nvCxnSpPr>
+          <p:cNvPr id="29" name="Connector 28"/>
+          <p:cNvCxnSpPr/>
+          <p:nvPr/>
+        </p:nvCxnSpPr>
+        <p:spPr>
+          <a:xfrm>
+            <a:off x="7703820" y="2331720"/>
+            <a:ext cx="0" cy="548640"/>
+          </a:xfrm>
+          <a:prstGeom prst="line">
+            <a:avLst/>
+          </a:prstGeom>
+          <a:ln w="15875">
+            <a:solidFill>
+              <a:srgbClr val="94A3B8"/>
+            </a:solidFill>
+            <a:tailEnd type="triangle" w="med" len="med"/>
+          </a:ln>
+        </p:spPr>
+        <p:style>
+          <a:lnRef idx="2">
+            <a:schemeClr val="accent1"/>
+          </a:lnRef>
+          <a:fillRef idx="0">
+            <a:schemeClr val="accent1"/>
+          </a:fillRef>
+          <a:effectRef idx="1">
+            <a:schemeClr val="accent1"/>
+          </a:effectRef>
+          <a:fontRef idx="minor">
+            <a:schemeClr val="tx1"/>
+          </a:fontRef>
+        </p:style>
+      </p:cxnSp>
+      <p:cxnSp>
+        <p:nvCxnSpPr>
+          <p:cNvPr id="30" name="Connector 29"/>
+          <p:cNvCxnSpPr/>
+          <p:nvPr/>
+        </p:nvCxnSpPr>
+        <p:spPr>
+          <a:xfrm>
+            <a:off x="10012680" y="2331720"/>
+            <a:ext cx="0" cy="274320"/>
+          </a:xfrm>
+          <a:prstGeom prst="line">
+            <a:avLst/>
+          </a:prstGeom>
+          <a:ln w="15875">
+            <a:solidFill>
+              <a:srgbClr val="059669"/>
+            </a:solidFill>
+          </a:ln>
+        </p:spPr>
+        <p:style>
+          <a:lnRef idx="2">
+            <a:schemeClr val="accent1"/>
+          </a:lnRef>
+          <a:fillRef idx="0">
+            <a:schemeClr val="accent1"/>
+          </a:fillRef>
+          <a:effectRef idx="1">
+            <a:schemeClr val="accent1"/>
+          </a:effectRef>
+          <a:fontRef idx="minor">
+            <a:schemeClr val="tx1"/>
+          </a:fontRef>
+        </p:style>
+      </p:cxnSp>
+      <p:cxnSp>
+        <p:nvCxnSpPr>
+          <p:cNvPr id="31" name="Connector 30"/>
+          <p:cNvCxnSpPr/>
+          <p:nvPr/>
+        </p:nvCxnSpPr>
+        <p:spPr>
+          <a:xfrm>
+            <a:off x="9212580" y="2606040"/>
+            <a:ext cx="1508760" cy="0"/>
+          </a:xfrm>
+          <a:prstGeom prst="line">
+            <a:avLst/>
+          </a:prstGeom>
+          <a:ln w="15875">
+            <a:solidFill>
+              <a:srgbClr val="059669"/>
+            </a:solidFill>
+          </a:ln>
+        </p:spPr>
+        <p:style>
+          <a:lnRef idx="2">
+            <a:schemeClr val="accent1"/>
+          </a:lnRef>
+          <a:fillRef idx="0">
+            <a:schemeClr val="accent1"/>
+          </a:fillRef>
+          <a:effectRef idx="1">
+            <a:schemeClr val="accent1"/>
+          </a:effectRef>
+          <a:fontRef idx="minor">
+            <a:schemeClr val="tx1"/>
+          </a:fontRef>
+        </p:style>
+      </p:cxnSp>
+      <p:sp>
+        <p:nvSpPr>
+          <p:cNvPr id="32" name="Rounded Rectangle 31"/>
+          <p:cNvSpPr/>
+          <p:nvPr/>
+        </p:nvSpPr>
+        <p:spPr>
+          <a:xfrm>
+            <a:off x="7040880" y="2880360"/>
+            <a:ext cx="1325880" cy="685800"/>
+          </a:xfrm>
+          <a:prstGeom prst="roundRect">
+            <a:avLst>
+              <a:gd name="adj" fmla="val 12000"/>
+            </a:avLst>
+          </a:prstGeom>
+          <a:solidFill>
+            <a:srgbClr val="FFFFFF"/>
+          </a:solidFill>
+          <a:ln w="12700">
+            <a:solidFill>
+              <a:srgbClr val="94A3B8"/>
+            </a:solidFill>
+          </a:ln>
+          <a:effectLst/>
+        </p:spPr>
+        <p:style>
+          <a:lnRef idx="1">
+            <a:schemeClr val="accent1"/>
+          </a:lnRef>
+          <a:fillRef idx="3">
+            <a:schemeClr val="accent1"/>
+          </a:fillRef>
+          <a:effectRef idx="2">
+            <a:schemeClr val="accent1"/>
+          </a:effectRef>
+          <a:fontRef idx="minor">
+            <a:schemeClr val="lt1"/>
+          </a:fontRef>
+        </p:style>
+        <p:txBody>
+          <a:bodyPr rtlCol="0" anchor="ctr" wrap="square" lIns="63500" rIns="63500" tIns="38100" bIns="38100"/>
+          <a:lstStyle/>
+          <a:p>
+            <a:pPr algn="ctr"/>
+            <a:r>
+              <a:rPr sz="1050" b="1">
+                <a:solidFill>
+                  <a:srgbClr val="0F172A"/>
+                </a:solidFill>
+                <a:latin typeface="Microsoft YaHei"/>
+                <a:ea typeface="Microsoft YaHei"/>
+              </a:rPr>
+              <a:t>显示 XComponent</a:t>
+            </a:r>
+          </a:p>
+          <a:p>
+            <a:pPr algn="ctr">
+              <a:spcBef>
+                <a:spcPts val="0"/>
+              </a:spcBef>
+            </a:pPr>
+            <a:r>
+              <a:rPr sz="850" b="0">
+                <a:solidFill>
+                  <a:srgbClr val="64748B"/>
+                </a:solidFill>
+                <a:latin typeface="Microsoft YaHei"/>
+                <a:ea typeface="Microsoft YaHei"/>
+              </a:rPr>
+              <a:t>宿主还是 UEC：争议 G</a:t>
+            </a:r>
+          </a:p>
+        </p:txBody>
+      </p:sp>
+      <p:cxnSp>
+        <p:nvCxnSpPr>
+          <p:cNvPr id="33" name="Connector 32"/>
+          <p:cNvCxnSpPr/>
+          <p:nvPr/>
+        </p:nvCxnSpPr>
+        <p:spPr>
+          <a:xfrm>
+            <a:off x="9212580" y="2606040"/>
+            <a:ext cx="0" cy="274320"/>
+          </a:xfrm>
+          <a:prstGeom prst="line">
+            <a:avLst/>
+          </a:prstGeom>
+          <a:ln w="15875">
+            <a:solidFill>
+              <a:srgbClr val="059669"/>
+            </a:solidFill>
+            <a:tailEnd type="triangle" w="med" len="med"/>
+          </a:ln>
+        </p:spPr>
+        <p:style>
+          <a:lnRef idx="2">
+            <a:schemeClr val="accent1"/>
+          </a:lnRef>
+          <a:fillRef idx="0">
+            <a:schemeClr val="accent1"/>
+          </a:fillRef>
+          <a:effectRef idx="1">
+            <a:schemeClr val="accent1"/>
+          </a:effectRef>
+          <a:fontRef idx="minor">
+            <a:schemeClr val="tx1"/>
+          </a:fontRef>
+        </p:style>
+      </p:cxnSp>
+      <p:sp>
+        <p:nvSpPr>
+          <p:cNvPr id="34" name="Rounded Rectangle 33"/>
+          <p:cNvSpPr/>
+          <p:nvPr/>
+        </p:nvSpPr>
+        <p:spPr>
+          <a:xfrm>
+            <a:off x="8503920" y="2880360"/>
+            <a:ext cx="1417320" cy="685800"/>
           </a:xfrm>
           <a:prstGeom prst="roundRect">
             <a:avLst>
@@ -10920,189 +11287,49 @@
           </a:fontRef>
         </p:style>
         <p:txBody>
-          <a:bodyPr rtlCol="0" anchor="ctr"/>
+          <a:bodyPr rtlCol="0" anchor="ctr" wrap="square" lIns="63500" rIns="63500" tIns="38100" bIns="38100"/>
           <a:lstStyle/>
           <a:p>
             <a:pPr algn="ctr"/>
-          </a:p>
-        </p:txBody>
-      </p:sp>
-      <p:sp>
-        <p:nvSpPr>
-          <p:cNvPr id="28" name="Rectangle 27"/>
-          <p:cNvSpPr/>
-          <p:nvPr/>
-        </p:nvSpPr>
-        <p:spPr>
-          <a:xfrm>
-            <a:off x="7068312" y="1801368"/>
-            <a:ext cx="54864" cy="420623"/>
-          </a:xfrm>
-          <a:prstGeom prst="rect">
-            <a:avLst/>
-          </a:prstGeom>
-          <a:solidFill>
-            <a:srgbClr val="059669"/>
-          </a:solidFill>
-          <a:ln>
-            <a:noFill/>
-          </a:ln>
-          <a:effectLst/>
-        </p:spPr>
-        <p:style>
-          <a:lnRef idx="1">
-            <a:schemeClr val="accent1"/>
-          </a:lnRef>
-          <a:fillRef idx="3">
-            <a:schemeClr val="accent1"/>
-          </a:fillRef>
-          <a:effectRef idx="2">
-            <a:schemeClr val="accent1"/>
-          </a:effectRef>
-          <a:fontRef idx="minor">
-            <a:schemeClr val="lt1"/>
-          </a:fontRef>
-        </p:style>
-        <p:txBody>
-          <a:bodyPr rtlCol="0" anchor="ctr"/>
-          <a:lstStyle/>
-          <a:p>
-            <a:pPr algn="ctr"/>
-          </a:p>
-        </p:txBody>
-      </p:sp>
-      <p:sp>
-        <p:nvSpPr>
-          <p:cNvPr id="29" name="TextBox 28"/>
-          <p:cNvSpPr txBox="1"/>
-          <p:nvPr/>
-        </p:nvSpPr>
-        <p:spPr>
-          <a:xfrm>
-            <a:off x="7168896" y="1691640"/>
-            <a:ext cx="4160520" cy="640080"/>
-          </a:xfrm>
-          <a:prstGeom prst="rect">
-            <a:avLst/>
-          </a:prstGeom>
-          <a:noFill/>
-        </p:spPr>
-        <p:txBody>
-          <a:bodyPr wrap="square" anchor="ctr" lIns="25400" rIns="25400" tIns="12700" bIns="12700">
-            <a:spAutoFit/>
-          </a:bodyPr>
-          <a:lstStyle/>
-          <a:p>
-            <a:pPr algn="l"/>
-            <a:r>
-              <a:rPr sz="1200" b="1">
+            <a:r>
+              <a:rPr sz="1050" b="1">
                 <a:solidFill>
                   <a:srgbClr val="0F172A"/>
                 </a:solidFill>
                 <a:latin typeface="Microsoft YaHei"/>
                 <a:ea typeface="Microsoft YaHei"/>
               </a:rPr>
-              <a:t>预览消费 + 三路分发（限流）</a:t>
-            </a:r>
-          </a:p>
-          <a:p>
-            <a:pPr algn="l">
+              <a:t>稳定帧门控</a:t>
+            </a:r>
+          </a:p>
+          <a:p>
+            <a:pPr algn="ctr">
               <a:spcBef>
-                <a:spcPts val="100"/>
+                <a:spcPts val="0"/>
               </a:spcBef>
             </a:pPr>
             <a:r>
-              <a:rPr sz="950" b="0">
+              <a:rPr sz="850" b="0">
                 <a:solidFill>
                   <a:srgbClr val="64748B"/>
                 </a:solidFill>
                 <a:latin typeface="Microsoft YaHei"/>
                 <a:ea typeface="Microsoft YaHei"/>
               </a:rPr>
-              <a:t>Surface / ImageReceiver 收帧；按用途降采样</a:t>
+              <a:t>独立模块 · motion meta</a:t>
             </a:r>
           </a:p>
         </p:txBody>
       </p:sp>
       <p:cxnSp>
         <p:nvCxnSpPr>
-          <p:cNvPr id="30" name="Connector 29"/>
+          <p:cNvPr id="35" name="Connector 34"/>
           <p:cNvCxnSpPr/>
           <p:nvPr/>
         </p:nvCxnSpPr>
         <p:spPr>
           <a:xfrm>
-            <a:off x="9212580" y="2331720"/>
-            <a:ext cx="0" cy="274320"/>
-          </a:xfrm>
-          <a:prstGeom prst="line">
-            <a:avLst/>
-          </a:prstGeom>
-          <a:ln w="15875">
-            <a:solidFill>
-              <a:srgbClr val="059669"/>
-            </a:solidFill>
-          </a:ln>
-        </p:spPr>
-        <p:style>
-          <a:lnRef idx="2">
-            <a:schemeClr val="accent1"/>
-          </a:lnRef>
-          <a:fillRef idx="0">
-            <a:schemeClr val="accent1"/>
-          </a:fillRef>
-          <a:effectRef idx="1">
-            <a:schemeClr val="accent1"/>
-          </a:effectRef>
-          <a:fontRef idx="minor">
-            <a:schemeClr val="tx1"/>
-          </a:fontRef>
-        </p:style>
-      </p:cxnSp>
-      <p:cxnSp>
-        <p:nvCxnSpPr>
-          <p:cNvPr id="31" name="Connector 30"/>
-          <p:cNvCxnSpPr/>
-          <p:nvPr/>
-        </p:nvCxnSpPr>
-        <p:spPr>
-          <a:xfrm>
-            <a:off x="7726679" y="2606040"/>
-            <a:ext cx="2971801" cy="0"/>
-          </a:xfrm>
-          <a:prstGeom prst="line">
-            <a:avLst/>
-          </a:prstGeom>
-          <a:ln w="15875">
-            <a:solidFill>
-              <a:srgbClr val="059669"/>
-            </a:solidFill>
-          </a:ln>
-        </p:spPr>
-        <p:style>
-          <a:lnRef idx="2">
-            <a:schemeClr val="accent1"/>
-          </a:lnRef>
-          <a:fillRef idx="0">
-            <a:schemeClr val="accent1"/>
-          </a:fillRef>
-          <a:effectRef idx="1">
-            <a:schemeClr val="accent1"/>
-          </a:effectRef>
-          <a:fontRef idx="minor">
-            <a:schemeClr val="tx1"/>
-          </a:fontRef>
-        </p:style>
-      </p:cxnSp>
-      <p:cxnSp>
-        <p:nvCxnSpPr>
-          <p:cNvPr id="32" name="Connector 31"/>
-          <p:cNvCxnSpPr/>
-          <p:nvPr/>
-        </p:nvCxnSpPr>
-        <p:spPr>
-          <a:xfrm>
-            <a:off x="7703820" y="2606040"/>
+            <a:off x="10721340" y="2606040"/>
             <a:ext cx="0" cy="274320"/>
           </a:xfrm>
           <a:prstGeom prst="line">
@@ -11132,13 +11359,13 @@
       </p:cxnSp>
       <p:sp>
         <p:nvSpPr>
-          <p:cNvPr id="33" name="Rounded Rectangle 32"/>
+          <p:cNvPr id="36" name="Rounded Rectangle 35"/>
           <p:cNvSpPr/>
           <p:nvPr/>
         </p:nvSpPr>
         <p:spPr>
           <a:xfrm>
-            <a:off x="7040880" y="2880360"/>
+            <a:off x="10058400" y="2880360"/>
             <a:ext cx="1325880" cy="685800"/>
           </a:xfrm>
           <a:prstGeom prst="roundRect">
@@ -11176,14 +11403,14 @@
           <a:p>
             <a:pPr algn="ctr"/>
             <a:r>
-              <a:rPr sz="1100" b="1">
+              <a:rPr sz="1050" b="1">
                 <a:solidFill>
                   <a:srgbClr val="0F172A"/>
                 </a:solidFill>
                 <a:latin typeface="Microsoft YaHei"/>
                 <a:ea typeface="Microsoft YaHei"/>
               </a:rPr>
-              <a:t>显示</a:t>
+              <a:t>AR 空间建模</a:t>
             </a:r>
           </a:p>
           <a:p>
@@ -11200,20 +11427,20 @@
                 <a:latin typeface="Microsoft YaHei"/>
                 <a:ea typeface="Microsoft YaHei"/>
               </a:rPr>
-              <a:t>用户所见画面</a:t>
+              <a:t>共用 B 或第三路 Output</a:t>
             </a:r>
           </a:p>
         </p:txBody>
       </p:sp>
       <p:cxnSp>
         <p:nvCxnSpPr>
-          <p:cNvPr id="34" name="Connector 33"/>
+          <p:cNvPr id="37" name="Connector 36"/>
           <p:cNvCxnSpPr/>
           <p:nvPr/>
         </p:nvCxnSpPr>
         <p:spPr>
           <a:xfrm>
-            <a:off x="9212580" y="2606040"/>
+            <a:off x="9212580" y="3566160"/>
             <a:ext cx="0" cy="274320"/>
           </a:xfrm>
           <a:prstGeom prst="line">
@@ -11243,14 +11470,14 @@
       </p:cxnSp>
       <p:sp>
         <p:nvSpPr>
-          <p:cNvPr id="35" name="Rounded Rectangle 34"/>
+          <p:cNvPr id="38" name="Rounded Rectangle 37"/>
           <p:cNvSpPr/>
           <p:nvPr/>
         </p:nvSpPr>
         <p:spPr>
           <a:xfrm>
-            <a:off x="8503920" y="2880360"/>
-            <a:ext cx="1417320" cy="685800"/>
+            <a:off x="8046720" y="3840480"/>
+            <a:ext cx="2331720" cy="594360"/>
           </a:xfrm>
           <a:prstGeom prst="roundRect">
             <a:avLst>
@@ -11294,7 +11521,7 @@
                 <a:latin typeface="Microsoft YaHei"/>
                 <a:ea typeface="Microsoft YaHei"/>
               </a:rPr>
-              <a:t>稳定帧门控</a:t>
+              <a:t>感知 / 端侧大模型</a:t>
             </a:r>
           </a:p>
           <a:p>
@@ -11311,20 +11538,20 @@
                 <a:latin typeface="Microsoft YaHei"/>
                 <a:ea typeface="Microsoft YaHei"/>
               </a:rPr>
-              <a:t>独立模块 · motion meta</a:t>
+              <a:t>仅在稳定帧触发；异步、过期丢弃</a:t>
             </a:r>
           </a:p>
         </p:txBody>
       </p:sp>
       <p:cxnSp>
         <p:nvCxnSpPr>
-          <p:cNvPr id="36" name="Connector 35"/>
+          <p:cNvPr id="39" name="Connector 38"/>
           <p:cNvCxnSpPr/>
           <p:nvPr/>
         </p:nvCxnSpPr>
         <p:spPr>
           <a:xfrm>
-            <a:off x="10721340" y="2606040"/>
+            <a:off x="9212580" y="4434840"/>
             <a:ext cx="0" cy="274320"/>
           </a:xfrm>
           <a:prstGeom prst="line">
@@ -11354,14 +11581,14 @@
       </p:cxnSp>
       <p:sp>
         <p:nvSpPr>
-          <p:cNvPr id="37" name="Rounded Rectangle 36"/>
+          <p:cNvPr id="40" name="Rounded Rectangle 39"/>
           <p:cNvSpPr/>
           <p:nvPr/>
         </p:nvSpPr>
         <p:spPr>
           <a:xfrm>
-            <a:off x="10058400" y="2880360"/>
-            <a:ext cx="1325880" cy="685800"/>
+            <a:off x="8046720" y="4709160"/>
+            <a:ext cx="2331720" cy="548640"/>
           </a:xfrm>
           <a:prstGeom prst="roundRect">
             <a:avLst>
@@ -11405,7 +11632,7 @@
                 <a:latin typeface="Microsoft YaHei"/>
                 <a:ea typeface="Microsoft YaHei"/>
               </a:rPr>
-              <a:t>AR 空间建模</a:t>
+              <a:t>分发服务 + 规则 → chips</a:t>
             </a:r>
           </a:p>
           <a:p>
@@ -11422,236 +11649,14 @@
                 <a:latin typeface="Microsoft YaHei"/>
                 <a:ea typeface="Microsoft YaHei"/>
               </a:rPr>
-              <a:t>自有帧率 / 分辨率</a:t>
-            </a:r>
-          </a:p>
-        </p:txBody>
-      </p:sp>
-      <p:cxnSp>
-        <p:nvCxnSpPr>
-          <p:cNvPr id="38" name="Connector 37"/>
-          <p:cNvCxnSpPr/>
-          <p:nvPr/>
-        </p:nvCxnSpPr>
-        <p:spPr>
-          <a:xfrm>
-            <a:off x="9212580" y="3566160"/>
-            <a:ext cx="0" cy="274320"/>
-          </a:xfrm>
-          <a:prstGeom prst="line">
-            <a:avLst/>
-          </a:prstGeom>
-          <a:ln w="15875">
-            <a:solidFill>
-              <a:srgbClr val="059669"/>
-            </a:solidFill>
-            <a:tailEnd type="triangle" w="med" len="med"/>
-          </a:ln>
-        </p:spPr>
-        <p:style>
-          <a:lnRef idx="2">
-            <a:schemeClr val="accent1"/>
-          </a:lnRef>
-          <a:fillRef idx="0">
-            <a:schemeClr val="accent1"/>
-          </a:fillRef>
-          <a:effectRef idx="1">
-            <a:schemeClr val="accent1"/>
-          </a:effectRef>
-          <a:fontRef idx="minor">
-            <a:schemeClr val="tx1"/>
-          </a:fontRef>
-        </p:style>
-      </p:cxnSp>
-      <p:sp>
-        <p:nvSpPr>
-          <p:cNvPr id="39" name="Rounded Rectangle 38"/>
-          <p:cNvSpPr/>
-          <p:nvPr/>
-        </p:nvSpPr>
-        <p:spPr>
-          <a:xfrm>
-            <a:off x="8046720" y="3840480"/>
-            <a:ext cx="2331720" cy="594360"/>
-          </a:xfrm>
-          <a:prstGeom prst="roundRect">
-            <a:avLst>
-              <a:gd name="adj" fmla="val 12000"/>
-            </a:avLst>
-          </a:prstGeom>
-          <a:solidFill>
-            <a:srgbClr val="FFFFFF"/>
-          </a:solidFill>
-          <a:ln w="12700">
-            <a:solidFill>
-              <a:srgbClr val="059669"/>
-            </a:solidFill>
-          </a:ln>
-          <a:effectLst/>
-        </p:spPr>
-        <p:style>
-          <a:lnRef idx="1">
-            <a:schemeClr val="accent1"/>
-          </a:lnRef>
-          <a:fillRef idx="3">
-            <a:schemeClr val="accent1"/>
-          </a:fillRef>
-          <a:effectRef idx="2">
-            <a:schemeClr val="accent1"/>
-          </a:effectRef>
-          <a:fontRef idx="minor">
-            <a:schemeClr val="lt1"/>
-          </a:fontRef>
-        </p:style>
-        <p:txBody>
-          <a:bodyPr rtlCol="0" anchor="ctr" wrap="square" lIns="63500" rIns="63500" tIns="38100" bIns="38100"/>
-          <a:lstStyle/>
-          <a:p>
-            <a:pPr algn="ctr"/>
-            <a:r>
-              <a:rPr sz="1100" b="1">
-                <a:solidFill>
-                  <a:srgbClr val="0F172A"/>
-                </a:solidFill>
-                <a:latin typeface="Microsoft YaHei"/>
-                <a:ea typeface="Microsoft YaHei"/>
-              </a:rPr>
-              <a:t>感知 / 端侧大模型</a:t>
-            </a:r>
-          </a:p>
-          <a:p>
-            <a:pPr algn="ctr">
-              <a:spcBef>
-                <a:spcPts val="0"/>
-              </a:spcBef>
-            </a:pPr>
-            <a:r>
-              <a:rPr sz="850" b="0">
-                <a:solidFill>
-                  <a:srgbClr val="64748B"/>
-                </a:solidFill>
-                <a:latin typeface="Microsoft YaHei"/>
-                <a:ea typeface="Microsoft YaHei"/>
-              </a:rPr>
-              <a:t>仅在稳定帧触发；异步、过期丢弃</a:t>
-            </a:r>
-          </a:p>
-        </p:txBody>
-      </p:sp>
-      <p:cxnSp>
-        <p:nvCxnSpPr>
-          <p:cNvPr id="40" name="Connector 39"/>
-          <p:cNvCxnSpPr/>
-          <p:nvPr/>
-        </p:nvCxnSpPr>
-        <p:spPr>
-          <a:xfrm>
-            <a:off x="9212580" y="4434840"/>
-            <a:ext cx="0" cy="274320"/>
-          </a:xfrm>
-          <a:prstGeom prst="line">
-            <a:avLst/>
-          </a:prstGeom>
-          <a:ln w="15875">
-            <a:solidFill>
-              <a:srgbClr val="059669"/>
-            </a:solidFill>
-            <a:tailEnd type="triangle" w="med" len="med"/>
-          </a:ln>
-        </p:spPr>
-        <p:style>
-          <a:lnRef idx="2">
-            <a:schemeClr val="accent1"/>
-          </a:lnRef>
-          <a:fillRef idx="0">
-            <a:schemeClr val="accent1"/>
-          </a:fillRef>
-          <a:effectRef idx="1">
-            <a:schemeClr val="accent1"/>
-          </a:effectRef>
-          <a:fontRef idx="minor">
-            <a:schemeClr val="tx1"/>
-          </a:fontRef>
-        </p:style>
-      </p:cxnSp>
+              <a:t>冷却 / 去重 / 点击执行</a:t>
+            </a:r>
+          </a:p>
+        </p:txBody>
+      </p:sp>
       <p:sp>
         <p:nvSpPr>
           <p:cNvPr id="41" name="Rounded Rectangle 40"/>
-          <p:cNvSpPr/>
-          <p:nvPr/>
-        </p:nvSpPr>
-        <p:spPr>
-          <a:xfrm>
-            <a:off x="8046720" y="4709160"/>
-            <a:ext cx="2331720" cy="548640"/>
-          </a:xfrm>
-          <a:prstGeom prst="roundRect">
-            <a:avLst>
-              <a:gd name="adj" fmla="val 12000"/>
-            </a:avLst>
-          </a:prstGeom>
-          <a:solidFill>
-            <a:srgbClr val="FFFFFF"/>
-          </a:solidFill>
-          <a:ln w="12700">
-            <a:solidFill>
-              <a:srgbClr val="059669"/>
-            </a:solidFill>
-          </a:ln>
-          <a:effectLst/>
-        </p:spPr>
-        <p:style>
-          <a:lnRef idx="1">
-            <a:schemeClr val="accent1"/>
-          </a:lnRef>
-          <a:fillRef idx="3">
-            <a:schemeClr val="accent1"/>
-          </a:fillRef>
-          <a:effectRef idx="2">
-            <a:schemeClr val="accent1"/>
-          </a:effectRef>
-          <a:fontRef idx="minor">
-            <a:schemeClr val="lt1"/>
-          </a:fontRef>
-        </p:style>
-        <p:txBody>
-          <a:bodyPr rtlCol="0" anchor="ctr" wrap="square" lIns="63500" rIns="63500" tIns="38100" bIns="38100"/>
-          <a:lstStyle/>
-          <a:p>
-            <a:pPr algn="ctr"/>
-            <a:r>
-              <a:rPr sz="1100" b="1">
-                <a:solidFill>
-                  <a:srgbClr val="0F172A"/>
-                </a:solidFill>
-                <a:latin typeface="Microsoft YaHei"/>
-                <a:ea typeface="Microsoft YaHei"/>
-              </a:rPr>
-              <a:t>分发服务 + 规则 → chips</a:t>
-            </a:r>
-          </a:p>
-          <a:p>
-            <a:pPr algn="ctr">
-              <a:spcBef>
-                <a:spcPts val="0"/>
-              </a:spcBef>
-            </a:pPr>
-            <a:r>
-              <a:rPr sz="850" b="0">
-                <a:solidFill>
-                  <a:srgbClr val="64748B"/>
-                </a:solidFill>
-                <a:latin typeface="Microsoft YaHei"/>
-                <a:ea typeface="Microsoft YaHei"/>
-              </a:rPr>
-              <a:t>冷却 / 去重 / 点击执行</a:t>
-            </a:r>
-          </a:p>
-        </p:txBody>
-      </p:sp>
-      <p:sp>
-        <p:nvSpPr>
-          <p:cNvPr id="42" name="Rounded Rectangle 41"/>
           <p:cNvSpPr/>
           <p:nvPr/>
         </p:nvSpPr>
@@ -11726,14 +11731,50 @@
       </p:sp>
       <p:cxnSp>
         <p:nvCxnSpPr>
+          <p:cNvPr id="42" name="Connector 41"/>
+          <p:cNvCxnSpPr/>
+          <p:nvPr/>
+        </p:nvCxnSpPr>
+        <p:spPr>
+          <a:xfrm>
+            <a:off x="5074920" y="1783080"/>
+            <a:ext cx="1965960" cy="0"/>
+          </a:xfrm>
+          <a:prstGeom prst="line">
+            <a:avLst/>
+          </a:prstGeom>
+          <a:ln w="19050">
+            <a:solidFill>
+              <a:srgbClr val="94A3B8"/>
+            </a:solidFill>
+            <a:tailEnd type="triangle" w="med" len="med"/>
+          </a:ln>
+        </p:spPr>
+        <p:style>
+          <a:lnRef idx="2">
+            <a:schemeClr val="accent1"/>
+          </a:lnRef>
+          <a:fillRef idx="0">
+            <a:schemeClr val="accent1"/>
+          </a:fillRef>
+          <a:effectRef idx="1">
+            <a:schemeClr val="accent1"/>
+          </a:effectRef>
+          <a:fontRef idx="minor">
+            <a:schemeClr val="tx1"/>
+          </a:fontRef>
+        </p:style>
+      </p:cxnSp>
+      <p:cxnSp>
+        <p:nvCxnSpPr>
           <p:cNvPr id="43" name="Connector 42"/>
           <p:cNvCxnSpPr/>
           <p:nvPr/>
         </p:nvCxnSpPr>
         <p:spPr>
           <a:xfrm>
-            <a:off x="5074920" y="1828800"/>
-            <a:ext cx="1965960" cy="0"/>
+            <a:off x="5074920" y="1965960"/>
+            <a:ext cx="3566160" cy="0"/>
           </a:xfrm>
           <a:prstGeom prst="line">
             <a:avLst/>
@@ -11768,8 +11809,8 @@
         </p:nvSpPr>
         <p:spPr>
           <a:xfrm>
-            <a:off x="5212080" y="1453895"/>
-            <a:ext cx="1737360" cy="237744"/>
+            <a:off x="5074920" y="1417319"/>
+            <a:ext cx="2011680" cy="237744"/>
           </a:xfrm>
           <a:prstGeom prst="roundRect">
             <a:avLst>
@@ -11811,7 +11852,7 @@
                 <a:latin typeface="Microsoft YaHei"/>
                 <a:ea typeface="Microsoft YaHei"/>
               </a:rPr>
-              <a:t>预览 Buffer + meta</a:t>
+              <a:t>A 显示 / B 分析 + meta</a:t>
             </a:r>
           </a:p>
         </p:txBody>
@@ -12352,7 +12393,7 @@
                 <a:latin typeface="Microsoft YaHei"/>
                 <a:ea typeface="Microsoft YaHei"/>
               </a:rPr>
-              <a:t>关键设计 ①｜预览流获取与三路分发</a:t>
+              <a:t>关键设计 ①｜预览流获取：显示 + 分析双 Surface</a:t>
             </a:r>
           </a:p>
         </p:txBody>
@@ -12388,7 +12429,7 @@
                 <a:latin typeface="Microsoft YaHei"/>
                 <a:ea typeface="Microsoft YaHei"/>
               </a:rPr>
-              <a:t>小艺提供 / 消费 Surface；配流由相机 App → 框架 → HAL 完成</a:t>
+              <a:t>一个 Surface 只有一个消费者；显示路被 RS 直接消费，应用层截不到帧 → 必须两路 Output</a:t>
             </a:r>
           </a:p>
         </p:txBody>
@@ -12727,7 +12768,7 @@
                 <a:latin typeface="Microsoft YaHei"/>
                 <a:ea typeface="Microsoft YaHei"/>
               </a:rPr>
-              <a:t>交换 Surface</a:t>
+              <a:t>交换两路 Surface</a:t>
             </a:r>
           </a:p>
           <a:p>
@@ -12744,7 +12785,7 @@
                 <a:latin typeface="Microsoft YaHei"/>
                 <a:ea typeface="Microsoft YaHei"/>
               </a:rPr>
-              <a:t>surfaceId · 尺寸</a:t>
+              <a:t>A：显示（XComponent）</a:t>
             </a:r>
           </a:p>
           <a:p>
@@ -12761,7 +12802,7 @@
                 <a:latin typeface="Microsoft YaHei"/>
                 <a:ea typeface="Microsoft YaHei"/>
               </a:rPr>
-              <a:t>BT709_FULL · fps</a:t>
+              <a:t>B：分析（ImageReceiver）</a:t>
             </a:r>
           </a:p>
         </p:txBody>
@@ -12926,7 +12967,7 @@
                 <a:latin typeface="Microsoft YaHei"/>
                 <a:ea typeface="Microsoft YaHei"/>
               </a:rPr>
-              <a:t>Session 增加</a:t>
+              <a:t>Session 加两路 Output</a:t>
             </a:r>
           </a:p>
           <a:p>
@@ -12943,7 +12984,7 @@
                 <a:latin typeface="Microsoft YaHei"/>
                 <a:ea typeface="Microsoft YaHei"/>
               </a:rPr>
-              <a:t>小艺 Output</a:t>
+              <a:t>各自 size / fps</a:t>
             </a:r>
           </a:p>
         </p:txBody>
@@ -13108,7 +13149,7 @@
                 <a:latin typeface="Microsoft YaHei"/>
                 <a:ea typeface="Microsoft YaHei"/>
               </a:rPr>
-              <a:t>预览 Buffer +</a:t>
+              <a:t>同一帧投 A、B</a:t>
             </a:r>
           </a:p>
           <a:p>
@@ -13273,7 +13314,7 @@
                 <a:latin typeface="Microsoft YaHei"/>
                 <a:ea typeface="Microsoft YaHei"/>
               </a:rPr>
-              <a:t>小艺分发</a:t>
+              <a:t>小艺消费 B</a:t>
             </a:r>
           </a:p>
           <a:p>
@@ -13290,7 +13331,7 @@
                 <a:latin typeface="Microsoft YaHei"/>
                 <a:ea typeface="Microsoft YaHei"/>
               </a:rPr>
-              <a:t>显示 / 模型 / AR</a:t>
+              <a:t>门控 / 模型 / AR</a:t>
             </a:r>
           </a:p>
         </p:txBody>
@@ -13406,7 +13447,7 @@
         <p:spPr>
           <a:xfrm>
             <a:off x="713232" y="2596896"/>
-            <a:ext cx="2066543" cy="292608"/>
+            <a:ext cx="4700016" cy="292608"/>
           </a:xfrm>
           <a:prstGeom prst="roundRect">
             <a:avLst>
@@ -13448,7 +13489,7 @@
                 <a:latin typeface="Microsoft YaHei"/>
                 <a:ea typeface="Microsoft YaHei"/>
               </a:rPr>
-              <a:t>三路分发（待拍板 B）</a:t>
+              <a:t>双 Surface：为什么不能单路 fork（B 已收敛）</a:t>
             </a:r>
           </a:p>
         </p:txBody>
@@ -13461,8 +13502,8 @@
         </p:nvSpPr>
         <p:spPr>
           <a:xfrm>
-            <a:off x="822960" y="3794760"/>
-            <a:ext cx="1554480" cy="822960"/>
+            <a:off x="777240" y="3977639"/>
+            <a:ext cx="1371600" cy="914400"/>
           </a:xfrm>
           <a:prstGeom prst="roundRect">
             <a:avLst>
@@ -13499,14 +13540,14 @@
           <a:p>
             <a:pPr algn="ctr"/>
             <a:r>
-              <a:rPr sz="1200" b="1">
+              <a:rPr sz="1150" b="1">
                 <a:solidFill>
                   <a:srgbClr val="0F172A"/>
                 </a:solidFill>
                 <a:latin typeface="Microsoft YaHei"/>
                 <a:ea typeface="Microsoft YaHei"/>
               </a:rPr>
-              <a:t>预览流</a:t>
+              <a:t>Camera HAL</a:t>
             </a:r>
           </a:p>
           <a:p>
@@ -13523,7 +13564,24 @@
                 <a:latin typeface="Microsoft YaHei"/>
                 <a:ea typeface="Microsoft YaHei"/>
               </a:rPr>
-              <a:t>HAL → Surface</a:t>
+              <a:t>生产者</a:t>
+            </a:r>
+          </a:p>
+          <a:p>
+            <a:pPr algn="ctr">
+              <a:spcBef>
+                <a:spcPts val="0"/>
+              </a:spcBef>
+            </a:pPr>
+            <a:r>
+              <a:rPr sz="850" b="0">
+                <a:solidFill>
+                  <a:srgbClr val="64748B"/>
+                </a:solidFill>
+                <a:latin typeface="Microsoft YaHei"/>
+                <a:ea typeface="Microsoft YaHei"/>
+              </a:rPr>
+              <a:t>同一帧投两路</a:t>
             </a:r>
           </a:p>
         </p:txBody>
@@ -13536,8 +13594,8 @@
         </p:nvCxnSpPr>
         <p:spPr>
           <a:xfrm>
-            <a:off x="2377440" y="4206240"/>
-            <a:ext cx="457200" cy="0"/>
+            <a:off x="2148840" y="4434840"/>
+            <a:ext cx="320040" cy="0"/>
           </a:xfrm>
           <a:prstGeom prst="line">
             <a:avLst/>
@@ -13571,8 +13629,8 @@
         </p:nvCxnSpPr>
         <p:spPr>
           <a:xfrm>
-            <a:off x="2834640" y="3246120"/>
-            <a:ext cx="0" cy="1920240"/>
+            <a:off x="2468880" y="3520440"/>
+            <a:ext cx="0" cy="1828800"/>
           </a:xfrm>
           <a:prstGeom prst="line">
             <a:avLst/>
@@ -13606,8 +13664,8 @@
         </p:nvCxnSpPr>
         <p:spPr>
           <a:xfrm>
-            <a:off x="2834640" y="3246120"/>
-            <a:ext cx="365760" cy="0"/>
+            <a:off x="2468880" y="3520440"/>
+            <a:ext cx="320040" cy="0"/>
           </a:xfrm>
           <a:prstGeom prst="line">
             <a:avLst/>
@@ -13642,8 +13700,341 @@
         </p:nvSpPr>
         <p:spPr>
           <a:xfrm>
-            <a:off x="3200400" y="2944368"/>
-            <a:ext cx="2011680" cy="603504"/>
+            <a:off x="2788920" y="3172968"/>
+            <a:ext cx="1600200" cy="694944"/>
+          </a:xfrm>
+          <a:prstGeom prst="roundRect">
+            <a:avLst>
+              <a:gd name="adj" fmla="val 12000"/>
+            </a:avLst>
+          </a:prstGeom>
+          <a:solidFill>
+            <a:srgbClr val="F1F5F9"/>
+          </a:solidFill>
+          <a:ln w="12700">
+            <a:solidFill>
+              <a:srgbClr val="94A3B8"/>
+            </a:solidFill>
+          </a:ln>
+          <a:effectLst/>
+        </p:spPr>
+        <p:style>
+          <a:lnRef idx="1">
+            <a:schemeClr val="accent1"/>
+          </a:lnRef>
+          <a:fillRef idx="3">
+            <a:schemeClr val="accent1"/>
+          </a:fillRef>
+          <a:effectRef idx="2">
+            <a:schemeClr val="accent1"/>
+          </a:effectRef>
+          <a:fontRef idx="minor">
+            <a:schemeClr val="lt1"/>
+          </a:fontRef>
+        </p:style>
+        <p:txBody>
+          <a:bodyPr rtlCol="0" anchor="ctr" wrap="square" lIns="63500" rIns="63500" tIns="38100" bIns="38100"/>
+          <a:lstStyle/>
+          <a:p>
+            <a:pPr algn="ctr"/>
+            <a:r>
+              <a:rPr sz="1100" b="1">
+                <a:solidFill>
+                  <a:srgbClr val="0F172A"/>
+                </a:solidFill>
+                <a:latin typeface="Microsoft YaHei"/>
+                <a:ea typeface="Microsoft YaHei"/>
+              </a:rPr>
+              <a:t>Surface A</a:t>
+            </a:r>
+          </a:p>
+          <a:p>
+            <a:pPr algn="ctr">
+              <a:spcBef>
+                <a:spcPts val="0"/>
+              </a:spcBef>
+            </a:pPr>
+            <a:r>
+              <a:rPr sz="850" b="0">
+                <a:solidFill>
+                  <a:srgbClr val="64748B"/>
+                </a:solidFill>
+                <a:latin typeface="Microsoft YaHei"/>
+                <a:ea typeface="Microsoft YaHei"/>
+              </a:rPr>
+              <a:t>显示路 · 全分辨率 30fps</a:t>
+            </a:r>
+          </a:p>
+        </p:txBody>
+      </p:sp>
+      <p:cxnSp>
+        <p:nvCxnSpPr>
+          <p:cNvPr id="30" name="Connector 29"/>
+          <p:cNvCxnSpPr/>
+          <p:nvPr/>
+        </p:nvCxnSpPr>
+        <p:spPr>
+          <a:xfrm>
+            <a:off x="4389120" y="3520440"/>
+            <a:ext cx="320040" cy="0"/>
+          </a:xfrm>
+          <a:prstGeom prst="line">
+            <a:avLst/>
+          </a:prstGeom>
+          <a:ln w="19050">
+            <a:solidFill>
+              <a:srgbClr val="94A3B8"/>
+            </a:solidFill>
+            <a:tailEnd type="triangle" w="med" len="med"/>
+          </a:ln>
+        </p:spPr>
+        <p:style>
+          <a:lnRef idx="2">
+            <a:schemeClr val="accent1"/>
+          </a:lnRef>
+          <a:fillRef idx="0">
+            <a:schemeClr val="accent1"/>
+          </a:fillRef>
+          <a:effectRef idx="1">
+            <a:schemeClr val="accent1"/>
+          </a:effectRef>
+          <a:fontRef idx="minor">
+            <a:schemeClr val="tx1"/>
+          </a:fontRef>
+        </p:style>
+      </p:cxnSp>
+      <p:sp>
+        <p:nvSpPr>
+          <p:cNvPr id="31" name="Rounded Rectangle 30"/>
+          <p:cNvSpPr/>
+          <p:nvPr/>
+        </p:nvSpPr>
+        <p:spPr>
+          <a:xfrm>
+            <a:off x="4709160" y="3172968"/>
+            <a:ext cx="1691640" cy="694944"/>
+          </a:xfrm>
+          <a:prstGeom prst="roundRect">
+            <a:avLst>
+              <a:gd name="adj" fmla="val 12000"/>
+            </a:avLst>
+          </a:prstGeom>
+          <a:solidFill>
+            <a:srgbClr val="FFFFFF"/>
+          </a:solidFill>
+          <a:ln w="12700">
+            <a:solidFill>
+              <a:srgbClr val="94A3B8"/>
+            </a:solidFill>
+          </a:ln>
+          <a:effectLst/>
+        </p:spPr>
+        <p:style>
+          <a:lnRef idx="1">
+            <a:schemeClr val="accent1"/>
+          </a:lnRef>
+          <a:fillRef idx="3">
+            <a:schemeClr val="accent1"/>
+          </a:fillRef>
+          <a:effectRef idx="2">
+            <a:schemeClr val="accent1"/>
+          </a:effectRef>
+          <a:fontRef idx="minor">
+            <a:schemeClr val="lt1"/>
+          </a:fontRef>
+        </p:style>
+        <p:txBody>
+          <a:bodyPr rtlCol="0" anchor="ctr" wrap="square" lIns="63500" rIns="63500" tIns="38100" bIns="38100"/>
+          <a:lstStyle/>
+          <a:p>
+            <a:pPr algn="ctr"/>
+            <a:r>
+              <a:rPr sz="1050" b="1">
+                <a:solidFill>
+                  <a:srgbClr val="0F172A"/>
+                </a:solidFill>
+                <a:latin typeface="Microsoft YaHei"/>
+                <a:ea typeface="Microsoft YaHei"/>
+              </a:rPr>
+              <a:t>RS 合成上屏</a:t>
+            </a:r>
+          </a:p>
+          <a:p>
+            <a:pPr algn="ctr">
+              <a:spcBef>
+                <a:spcPts val="0"/>
+              </a:spcBef>
+            </a:pPr>
+            <a:r>
+              <a:rPr sz="850" b="0">
+                <a:solidFill>
+                  <a:srgbClr val="64748B"/>
+                </a:solidFill>
+                <a:latin typeface="Microsoft YaHei"/>
+                <a:ea typeface="Microsoft YaHei"/>
+              </a:rPr>
+              <a:t>应用层不在队列上</a:t>
+            </a:r>
+          </a:p>
+        </p:txBody>
+      </p:sp>
+      <p:cxnSp>
+        <p:nvCxnSpPr>
+          <p:cNvPr id="32" name="Connector 31"/>
+          <p:cNvCxnSpPr/>
+          <p:nvPr/>
+        </p:nvCxnSpPr>
+        <p:spPr>
+          <a:xfrm>
+            <a:off x="2468880" y="5349240"/>
+            <a:ext cx="320040" cy="0"/>
+          </a:xfrm>
+          <a:prstGeom prst="line">
+            <a:avLst/>
+          </a:prstGeom>
+          <a:ln w="19050">
+            <a:solidFill>
+              <a:srgbClr val="2563EB"/>
+            </a:solidFill>
+            <a:tailEnd type="triangle" w="med" len="med"/>
+          </a:ln>
+        </p:spPr>
+        <p:style>
+          <a:lnRef idx="2">
+            <a:schemeClr val="accent1"/>
+          </a:lnRef>
+          <a:fillRef idx="0">
+            <a:schemeClr val="accent1"/>
+          </a:fillRef>
+          <a:effectRef idx="1">
+            <a:schemeClr val="accent1"/>
+          </a:effectRef>
+          <a:fontRef idx="minor">
+            <a:schemeClr val="tx1"/>
+          </a:fontRef>
+        </p:style>
+      </p:cxnSp>
+      <p:sp>
+        <p:nvSpPr>
+          <p:cNvPr id="33" name="Rounded Rectangle 32"/>
+          <p:cNvSpPr/>
+          <p:nvPr/>
+        </p:nvSpPr>
+        <p:spPr>
+          <a:xfrm>
+            <a:off x="2788920" y="5001768"/>
+            <a:ext cx="1600200" cy="694944"/>
+          </a:xfrm>
+          <a:prstGeom prst="roundRect">
+            <a:avLst>
+              <a:gd name="adj" fmla="val 12000"/>
+            </a:avLst>
+          </a:prstGeom>
+          <a:solidFill>
+            <a:srgbClr val="D1FAE5"/>
+          </a:solidFill>
+          <a:ln w="12700">
+            <a:solidFill>
+              <a:srgbClr val="059669"/>
+            </a:solidFill>
+          </a:ln>
+          <a:effectLst/>
+        </p:spPr>
+        <p:style>
+          <a:lnRef idx="1">
+            <a:schemeClr val="accent1"/>
+          </a:lnRef>
+          <a:fillRef idx="3">
+            <a:schemeClr val="accent1"/>
+          </a:fillRef>
+          <a:effectRef idx="2">
+            <a:schemeClr val="accent1"/>
+          </a:effectRef>
+          <a:fontRef idx="minor">
+            <a:schemeClr val="lt1"/>
+          </a:fontRef>
+        </p:style>
+        <p:txBody>
+          <a:bodyPr rtlCol="0" anchor="ctr" wrap="square" lIns="63500" rIns="63500" tIns="38100" bIns="38100"/>
+          <a:lstStyle/>
+          <a:p>
+            <a:pPr algn="ctr"/>
+            <a:r>
+              <a:rPr sz="1100" b="1">
+                <a:solidFill>
+                  <a:srgbClr val="0F172A"/>
+                </a:solidFill>
+                <a:latin typeface="Microsoft YaHei"/>
+                <a:ea typeface="Microsoft YaHei"/>
+              </a:rPr>
+              <a:t>Surface B</a:t>
+            </a:r>
+          </a:p>
+          <a:p>
+            <a:pPr algn="ctr">
+              <a:spcBef>
+                <a:spcPts val="0"/>
+              </a:spcBef>
+            </a:pPr>
+            <a:r>
+              <a:rPr sz="850" b="0">
+                <a:solidFill>
+                  <a:srgbClr val="64748B"/>
+                </a:solidFill>
+                <a:latin typeface="Microsoft YaHei"/>
+                <a:ea typeface="Microsoft YaHei"/>
+              </a:rPr>
+              <a:t>分析路 · 小图 1～5fps</a:t>
+            </a:r>
+          </a:p>
+        </p:txBody>
+      </p:sp>
+      <p:cxnSp>
+        <p:nvCxnSpPr>
+          <p:cNvPr id="34" name="Connector 33"/>
+          <p:cNvCxnSpPr/>
+          <p:nvPr/>
+        </p:nvCxnSpPr>
+        <p:spPr>
+          <a:xfrm>
+            <a:off x="4389120" y="5349240"/>
+            <a:ext cx="320040" cy="0"/>
+          </a:xfrm>
+          <a:prstGeom prst="line">
+            <a:avLst/>
+          </a:prstGeom>
+          <a:ln w="19050">
+            <a:solidFill>
+              <a:srgbClr val="059669"/>
+            </a:solidFill>
+            <a:tailEnd type="triangle" w="med" len="med"/>
+          </a:ln>
+        </p:spPr>
+        <p:style>
+          <a:lnRef idx="2">
+            <a:schemeClr val="accent1"/>
+          </a:lnRef>
+          <a:fillRef idx="0">
+            <a:schemeClr val="accent1"/>
+          </a:fillRef>
+          <a:effectRef idx="1">
+            <a:schemeClr val="accent1"/>
+          </a:effectRef>
+          <a:fontRef idx="minor">
+            <a:schemeClr val="tx1"/>
+          </a:fontRef>
+        </p:style>
+      </p:cxnSp>
+      <p:sp>
+        <p:nvSpPr>
+          <p:cNvPr id="35" name="Rounded Rectangle 34"/>
+          <p:cNvSpPr/>
+          <p:nvPr/>
+        </p:nvSpPr>
+        <p:spPr>
+          <a:xfrm>
+            <a:off x="4709160" y="5001768"/>
+            <a:ext cx="1691640" cy="694944"/>
           </a:xfrm>
           <a:prstGeom prst="roundRect">
             <a:avLst>
@@ -13680,14 +14071,14 @@
           <a:p>
             <a:pPr algn="ctr"/>
             <a:r>
-              <a:rPr sz="1100" b="1">
+              <a:rPr sz="1050" b="1">
                 <a:solidFill>
                   <a:srgbClr val="0F172A"/>
                 </a:solidFill>
                 <a:latin typeface="Microsoft YaHei"/>
                 <a:ea typeface="Microsoft YaHei"/>
               </a:rPr>
-              <a:t>显示</a:t>
+              <a:t>小艺 ImageReceiver</a:t>
             </a:r>
           </a:p>
           <a:p>
@@ -13704,101 +14095,43 @@
                 <a:latin typeface="Microsoft YaHei"/>
                 <a:ea typeface="Microsoft YaHei"/>
               </a:rPr>
-              <a:t>全分辨率 · 30fps</a:t>
-            </a:r>
-          </a:p>
-        </p:txBody>
-      </p:sp>
-      <p:cxnSp>
-        <p:nvCxnSpPr>
-          <p:cNvPr id="30" name="Connector 29"/>
-          <p:cNvCxnSpPr/>
-          <p:nvPr/>
-        </p:nvCxnSpPr>
-        <p:spPr>
-          <a:xfrm>
-            <a:off x="2834640" y="4206240"/>
-            <a:ext cx="365760" cy="0"/>
-          </a:xfrm>
-          <a:prstGeom prst="line">
-            <a:avLst/>
-          </a:prstGeom>
-          <a:ln w="19050">
-            <a:solidFill>
-              <a:srgbClr val="2563EB"/>
-            </a:solidFill>
-            <a:tailEnd type="triangle" w="med" len="med"/>
-          </a:ln>
-        </p:spPr>
-        <p:style>
-          <a:lnRef idx="2">
-            <a:schemeClr val="accent1"/>
-          </a:lnRef>
-          <a:fillRef idx="0">
-            <a:schemeClr val="accent1"/>
-          </a:fillRef>
-          <a:effectRef idx="1">
-            <a:schemeClr val="accent1"/>
-          </a:effectRef>
-          <a:fontRef idx="minor">
-            <a:schemeClr val="tx1"/>
-          </a:fontRef>
-        </p:style>
-      </p:cxnSp>
-      <p:sp>
-        <p:nvSpPr>
-          <p:cNvPr id="31" name="Rounded Rectangle 30"/>
-          <p:cNvSpPr/>
-          <p:nvPr/>
-        </p:nvSpPr>
-        <p:spPr>
-          <a:xfrm>
-            <a:off x="3200400" y="3904487"/>
-            <a:ext cx="2011680" cy="603504"/>
-          </a:xfrm>
-          <a:prstGeom prst="roundRect">
-            <a:avLst>
-              <a:gd name="adj" fmla="val 12000"/>
-            </a:avLst>
-          </a:prstGeom>
-          <a:solidFill>
-            <a:srgbClr val="FFFFFF"/>
-          </a:solidFill>
-          <a:ln w="12700">
-            <a:solidFill>
-              <a:srgbClr val="059669"/>
-            </a:solidFill>
-          </a:ln>
-          <a:effectLst/>
-        </p:spPr>
-        <p:style>
-          <a:lnRef idx="1">
-            <a:schemeClr val="accent1"/>
-          </a:lnRef>
-          <a:fillRef idx="3">
-            <a:schemeClr val="accent1"/>
-          </a:fillRef>
-          <a:effectRef idx="2">
-            <a:schemeClr val="accent1"/>
-          </a:effectRef>
-          <a:fontRef idx="minor">
-            <a:schemeClr val="lt1"/>
-          </a:fontRef>
-        </p:style>
-        <p:txBody>
-          <a:bodyPr rtlCol="0" anchor="ctr" wrap="square" lIns="63500" rIns="63500" tIns="38100" bIns="38100"/>
+              <a:t>acquire → 处理 → release</a:t>
+            </a:r>
+          </a:p>
+        </p:txBody>
+      </p:sp>
+      <p:sp>
+        <p:nvSpPr>
+          <p:cNvPr id="36" name="TextBox 35"/>
+          <p:cNvSpPr txBox="1"/>
+          <p:nvPr/>
+        </p:nvSpPr>
+        <p:spPr>
+          <a:xfrm>
+            <a:off x="2788920" y="4224528"/>
+            <a:ext cx="3611880" cy="457200"/>
+          </a:xfrm>
+          <a:prstGeom prst="rect">
+            <a:avLst/>
+          </a:prstGeom>
+          <a:noFill/>
+        </p:spPr>
+        <p:txBody>
+          <a:bodyPr wrap="square" anchor="t" lIns="25400" rIns="25400" tIns="12700" bIns="12700">
+            <a:spAutoFit/>
+          </a:bodyPr>
           <a:lstStyle/>
           <a:p>
             <a:pPr algn="ctr"/>
             <a:r>
-              <a:rPr sz="1100" b="1">
-                <a:solidFill>
-                  <a:srgbClr val="0F172A"/>
-                </a:solidFill>
-                <a:latin typeface="Microsoft YaHei"/>
-                <a:ea typeface="Microsoft YaHei"/>
-              </a:rPr>
-              <a:t>模型</a:t>
+              <a:rPr sz="950" b="1">
+                <a:solidFill>
+                  <a:srgbClr val="4F46E5"/>
+                </a:solidFill>
+                <a:latin typeface="Microsoft YaHei"/>
+                <a:ea typeface="Microsoft YaHei"/>
+              </a:rPr>
+              <a:t>规则：一个 Surface 只有一个消费者</a:t>
             </a:r>
           </a:p>
           <a:p>
@@ -13815,132 +14148,21 @@
                 <a:latin typeface="Microsoft YaHei"/>
                 <a:ea typeface="Microsoft YaHei"/>
               </a:rPr>
-              <a:t>小图 · 1～5fps · 稳定帧触发</a:t>
-            </a:r>
-          </a:p>
-        </p:txBody>
-      </p:sp>
-      <p:cxnSp>
-        <p:nvCxnSpPr>
-          <p:cNvPr id="32" name="Connector 31"/>
-          <p:cNvCxnSpPr/>
-          <p:nvPr/>
-        </p:nvCxnSpPr>
-        <p:spPr>
-          <a:xfrm>
-            <a:off x="2834640" y="5166360"/>
-            <a:ext cx="365760" cy="0"/>
-          </a:xfrm>
-          <a:prstGeom prst="line">
-            <a:avLst/>
-          </a:prstGeom>
-          <a:ln w="19050">
-            <a:solidFill>
-              <a:srgbClr val="2563EB"/>
-            </a:solidFill>
-            <a:tailEnd type="triangle" w="med" len="med"/>
-          </a:ln>
-        </p:spPr>
-        <p:style>
-          <a:lnRef idx="2">
-            <a:schemeClr val="accent1"/>
-          </a:lnRef>
-          <a:fillRef idx="0">
-            <a:schemeClr val="accent1"/>
-          </a:fillRef>
-          <a:effectRef idx="1">
-            <a:schemeClr val="accent1"/>
-          </a:effectRef>
-          <a:fontRef idx="minor">
-            <a:schemeClr val="tx1"/>
-          </a:fontRef>
-        </p:style>
-      </p:cxnSp>
-      <p:sp>
-        <p:nvSpPr>
-          <p:cNvPr id="33" name="Rounded Rectangle 32"/>
-          <p:cNvSpPr/>
-          <p:nvPr/>
-        </p:nvSpPr>
-        <p:spPr>
-          <a:xfrm>
-            <a:off x="3200400" y="4864608"/>
-            <a:ext cx="2011680" cy="603504"/>
-          </a:xfrm>
-          <a:prstGeom prst="roundRect">
-            <a:avLst>
-              <a:gd name="adj" fmla="val 12000"/>
-            </a:avLst>
-          </a:prstGeom>
-          <a:solidFill>
-            <a:srgbClr val="FFFFFF"/>
-          </a:solidFill>
-          <a:ln w="12700">
-            <a:solidFill>
-              <a:srgbClr val="059669"/>
-            </a:solidFill>
-          </a:ln>
-          <a:effectLst/>
-        </p:spPr>
-        <p:style>
-          <a:lnRef idx="1">
-            <a:schemeClr val="accent1"/>
-          </a:lnRef>
-          <a:fillRef idx="3">
-            <a:schemeClr val="accent1"/>
-          </a:fillRef>
-          <a:effectRef idx="2">
-            <a:schemeClr val="accent1"/>
-          </a:effectRef>
-          <a:fontRef idx="minor">
-            <a:schemeClr val="lt1"/>
-          </a:fontRef>
-        </p:style>
-        <p:txBody>
-          <a:bodyPr rtlCol="0" anchor="ctr" wrap="square" lIns="63500" rIns="63500" tIns="38100" bIns="38100"/>
-          <a:lstStyle/>
-          <a:p>
-            <a:pPr algn="ctr"/>
-            <a:r>
-              <a:rPr sz="1100" b="1">
-                <a:solidFill>
-                  <a:srgbClr val="0F172A"/>
-                </a:solidFill>
-                <a:latin typeface="Microsoft YaHei"/>
-                <a:ea typeface="Microsoft YaHei"/>
-              </a:rPr>
-              <a:t>AR</a:t>
-            </a:r>
-          </a:p>
-          <a:p>
-            <a:pPr algn="ctr">
-              <a:spcBef>
-                <a:spcPts val="0"/>
-              </a:spcBef>
-            </a:pPr>
-            <a:r>
-              <a:rPr sz="850" b="0">
-                <a:solidFill>
-                  <a:srgbClr val="64748B"/>
-                </a:solidFill>
-                <a:latin typeface="Microsoft YaHei"/>
-                <a:ea typeface="Microsoft YaHei"/>
-              </a:rPr>
-              <a:t>按算法需求单独约定</a:t>
-            </a:r>
-          </a:p>
-        </p:txBody>
-      </p:sp>
-      <p:sp>
-        <p:nvSpPr>
-          <p:cNvPr id="34" name="TextBox 33"/>
+              <a:t>HAL flush → RS 立刻 acquire → 上屏，小艺没有插手机会</a:t>
+            </a:r>
+          </a:p>
+        </p:txBody>
+      </p:sp>
+      <p:sp>
+        <p:nvSpPr>
+          <p:cNvPr id="37" name="TextBox 36"/>
           <p:cNvSpPr txBox="1"/>
           <p:nvPr/>
         </p:nvSpPr>
         <p:spPr>
           <a:xfrm>
-            <a:off x="5349240" y="3017520"/>
-            <a:ext cx="1143000" cy="1097280"/>
+            <a:off x="777240" y="5760720"/>
+            <a:ext cx="5577840" cy="411480"/>
           </a:xfrm>
           <a:prstGeom prst="rect">
             <a:avLst/>
@@ -13955,127 +14177,21 @@
           <a:p>
             <a:pPr algn="l"/>
             <a:r>
-              <a:rPr sz="1000" b="1">
-                <a:solidFill>
-                  <a:srgbClr val="2563EB"/>
-                </a:solidFill>
-                <a:latin typeface="Microsoft YaHei"/>
-                <a:ea typeface="Microsoft YaHei"/>
-              </a:rPr>
-              <a:t>B1 多 Output</a:t>
-            </a:r>
-          </a:p>
-          <a:p>
-            <a:pPr algn="l">
-              <a:spcBef>
-                <a:spcPts val="100"/>
-              </a:spcBef>
-            </a:pPr>
-            <a:r>
-              <a:rPr sz="850" b="0">
-                <a:solidFill>
-                  <a:srgbClr val="64748B"/>
-                </a:solidFill>
-                <a:latin typeface="Microsoft YaHei"/>
-                <a:ea typeface="Microsoft YaHei"/>
-              </a:rPr>
-              <a:t>相机一次出三路，各路独立分辨率；少拷贝，接口复杂</a:t>
-            </a:r>
-          </a:p>
-        </p:txBody>
-      </p:sp>
-      <p:sp>
-        <p:nvSpPr>
-          <p:cNvPr id="35" name="TextBox 34"/>
-          <p:cNvSpPr txBox="1"/>
-          <p:nvPr/>
-        </p:nvSpPr>
-        <p:spPr>
-          <a:xfrm>
-            <a:off x="5349240" y="4343400"/>
-            <a:ext cx="1143000" cy="1280160"/>
-          </a:xfrm>
-          <a:prstGeom prst="rect">
-            <a:avLst/>
-          </a:prstGeom>
-          <a:noFill/>
-        </p:spPr>
-        <p:txBody>
-          <a:bodyPr wrap="square" anchor="t" lIns="25400" rIns="25400" tIns="12700" bIns="12700">
-            <a:spAutoFit/>
-          </a:bodyPr>
-          <a:lstStyle/>
-          <a:p>
-            <a:pPr algn="l"/>
-            <a:r>
-              <a:rPr sz="1000" b="1">
-                <a:solidFill>
-                  <a:srgbClr val="059669"/>
-                </a:solidFill>
-                <a:latin typeface="Microsoft YaHei"/>
-                <a:ea typeface="Microsoft YaHei"/>
-              </a:rPr>
-              <a:t>B2 单路 fork</a:t>
-            </a:r>
-          </a:p>
-          <a:p>
-            <a:pPr algn="l">
-              <a:spcBef>
-                <a:spcPts val="100"/>
-              </a:spcBef>
-            </a:pPr>
-            <a:r>
-              <a:rPr sz="850" b="0">
-                <a:solidFill>
-                  <a:srgbClr val="64748B"/>
-                </a:solidFill>
-                <a:latin typeface="Microsoft YaHei"/>
-                <a:ea typeface="Microsoft YaHei"/>
-              </a:rPr>
-              <a:t>小艺收一路后分发；接口简单先跑通，需应用内降采样</a:t>
-            </a:r>
-          </a:p>
-        </p:txBody>
-      </p:sp>
-      <p:sp>
-        <p:nvSpPr>
-          <p:cNvPr id="36" name="TextBox 35"/>
-          <p:cNvSpPr txBox="1"/>
-          <p:nvPr/>
-        </p:nvSpPr>
-        <p:spPr>
-          <a:xfrm>
-            <a:off x="822960" y="5715000"/>
-            <a:ext cx="5486400" cy="411480"/>
-          </a:xfrm>
-          <a:prstGeom prst="rect">
-            <a:avLst/>
-          </a:prstGeom>
-          <a:noFill/>
-        </p:spPr>
-        <p:txBody>
-          <a:bodyPr wrap="square" anchor="t" lIns="25400" rIns="25400" tIns="12700" bIns="12700">
-            <a:spAutoFit/>
-          </a:bodyPr>
-          <a:lstStyle/>
-          <a:p>
-            <a:pPr algn="l"/>
-            <a:r>
-              <a:rPr sz="1000" b="1">
+              <a:rPr sz="950" b="1">
                 <a:solidFill>
                   <a:srgbClr val="E11D48"/>
                 </a:solidFill>
                 <a:latin typeface="Microsoft YaHei"/>
                 <a:ea typeface="Microsoft YaHei"/>
               </a:rPr>
-              <a:t>禁止：三路全帧率全分辨率裸拷贝（功耗 / 发热 / 拖垮预览）</a:t>
-            </a:r>
-          </a:p>
-        </p:txBody>
-      </p:sp>
-      <p:sp>
-        <p:nvSpPr>
-          <p:cNvPr id="37" name="Rounded Rectangle 36"/>
+              <a:t>不做：小艺先消费 B 再转发到显示（多一次拷贝 + ≥1 帧延迟）；AR 尺寸不同再加第三路 Output</a:t>
+            </a:r>
+          </a:p>
+        </p:txBody>
+      </p:sp>
+      <p:sp>
+        <p:nvSpPr>
+          <p:cNvPr id="38" name="Rounded Rectangle 37"/>
           <p:cNvSpPr/>
           <p:nvPr/>
         </p:nvSpPr>
@@ -14123,7 +14239,7 @@
       </p:sp>
       <p:sp>
         <p:nvSpPr>
-          <p:cNvPr id="38" name="Rounded Rectangle 37"/>
+          <p:cNvPr id="39" name="Rounded Rectangle 38"/>
           <p:cNvSpPr/>
           <p:nvPr/>
         </p:nvSpPr>
@@ -14179,7 +14295,7 @@
       </p:sp>
       <p:sp>
         <p:nvSpPr>
-          <p:cNvPr id="39" name="TextBox 38"/>
+          <p:cNvPr id="40" name="TextBox 39"/>
           <p:cNvSpPr txBox="1"/>
           <p:nvPr/>
         </p:nvSpPr>
@@ -14233,7 +14349,7 @@
           <a:p>
             <a:pPr>
               <a:spcBef>
-                <a:spcPts val="700"/>
+                <a:spcPts val="600"/>
               </a:spcBef>
             </a:pPr>
             <a:r>
@@ -14270,7 +14386,7 @@
           <a:p>
             <a:pPr>
               <a:spcBef>
-                <a:spcPts val="700"/>
+                <a:spcPts val="600"/>
               </a:spcBef>
             </a:pPr>
             <a:r>
@@ -14307,7 +14423,7 @@
           <a:p>
             <a:pPr>
               <a:spcBef>
-                <a:spcPts val="700"/>
+                <a:spcPts val="600"/>
               </a:spcBef>
             </a:pPr>
             <a:r>
@@ -14344,7 +14460,7 @@
           <a:p>
             <a:pPr>
               <a:spcBef>
-                <a:spcPts val="700"/>
+                <a:spcPts val="600"/>
               </a:spcBef>
             </a:pPr>
             <a:r>
@@ -14375,7 +14491,44 @@
                 <a:latin typeface="Microsoft YaHei"/>
                 <a:ea typeface="Microsoft YaHei"/>
               </a:rPr>
-              <a:t>：谁创建、谁销毁、切 Tab 时谁先停</a:t>
+              <a:t>：A 由 XComponent 所在进程建、B 由小艺建；切 Tab 时谁先停</a:t>
+            </a:r>
+          </a:p>
+          <a:p>
+            <a:pPr>
+              <a:spcBef>
+                <a:spcPts val="600"/>
+              </a:spcBef>
+            </a:pPr>
+            <a:r>
+              <a:rPr sz="1050" b="1">
+                <a:solidFill>
+                  <a:srgbClr val="D97706"/>
+                </a:solidFill>
+                <a:latin typeface="Microsoft YaHei"/>
+                <a:ea typeface="Microsoft YaHei"/>
+              </a:rPr>
+              <a:t>• </a:t>
+            </a:r>
+            <a:r>
+              <a:rPr sz="1050" b="1">
+                <a:solidFill>
+                  <a:srgbClr val="0F172A"/>
+                </a:solidFill>
+                <a:latin typeface="Microsoft YaHei"/>
+                <a:ea typeface="Microsoft YaHei"/>
+              </a:rPr>
+              <a:t>能力协商</a:t>
+            </a:r>
+            <a:r>
+              <a:rPr sz="1050" b="0">
+                <a:solidFill>
+                  <a:srgbClr val="0F172A"/>
+                </a:solidFill>
+                <a:latin typeface="Microsoft YaHei"/>
+                <a:ea typeface="Microsoft YaHei"/>
+              </a:rPr>
+              <a:t>：HAL 最大并发 Output 数、各路允许的分辨率组合</a:t>
             </a:r>
           </a:p>
         </p:txBody>
@@ -18472,7 +18625,7 @@
                 <a:latin typeface="Microsoft YaHei"/>
                 <a:ea typeface="Microsoft YaHei"/>
               </a:rPr>
-              <a:t>→ sizes / formats / fps / 多 Output / motion meta / 按需深度 / 可否 Pause</a:t>
+              <a:t>→ sizes / formats / fps / 最大并发 Output 数 / motion meta / 按需深度 / 可否 Pause</a:t>
             </a:r>
           </a:p>
         </p:txBody>
@@ -18636,7 +18789,7 @@
                 <a:latin typeface="Microsoft YaHei"/>
                 <a:ea typeface="Microsoft YaHei"/>
               </a:rPr>
-              <a:t>ProvideSurface</a:t>
+              <a:t>ProvideSurfaces</a:t>
             </a:r>
           </a:p>
         </p:txBody>
@@ -18672,7 +18825,7 @@
                 <a:latin typeface="Microsoft YaHei"/>
                 <a:ea typeface="Microsoft YaHei"/>
               </a:rPr>
-              <a:t>surfaceId 交换（争议 A）</a:t>
+              <a:t>[{surfaceId, role: DISPLAY | ANALYSIS}] 两路（争议 A：各由谁建）</a:t>
             </a:r>
           </a:p>
         </p:txBody>
@@ -18744,7 +18897,7 @@
                 <a:latin typeface="Microsoft YaHei"/>
                 <a:ea typeface="Microsoft YaHei"/>
               </a:rPr>
-              <a:t>size · format · fps · needMotionMeta</a:t>
+              <a:t>outputs: [{surfaceId, size, format, fps, role}] · needMotionMeta</a:t>
             </a:r>
           </a:p>
         </p:txBody>
@@ -23508,7 +23661,7 @@
                 <a:latin typeface="Microsoft YaHei"/>
                 <a:ea typeface="Microsoft YaHei"/>
               </a:rPr>
-              <a:t>三路分发 &amp; 门控参数</a:t>
+              <a:t>多路 Output &amp; 门控参数</a:t>
             </a:r>
           </a:p>
         </p:txBody>
@@ -23544,7 +23697,7 @@
                 <a:latin typeface="Microsoft YaHei"/>
                 <a:ea typeface="Microsoft YaHei"/>
               </a:rPr>
-              <a:t>多 Output vs 单路 fork；阈值 / K 帧 / M ms</a:t>
+              <a:t>B 已收敛双 Surface；AR 是否第三路待定；门控阈值</a:t>
             </a:r>
           </a:p>
         </p:txBody>
@@ -23580,7 +23733,7 @@
                 <a:latin typeface="Microsoft YaHei"/>
                 <a:ea typeface="Microsoft YaHei"/>
               </a:rPr>
-              <a:t>先 B2 跑通，能力允许升 B1</a:t>
+              <a:t>确认 HAL 并发 Output 上限；门控参数样机调</a:t>
             </a:r>
           </a:p>
         </p:txBody>

</xml_diff>